<commit_message>
Keep presentation typography consistent
The reusable presentation workflow now specifies Pretendard for every visible Korean text role, including quotations and source lines. The bundled PowerPoint template was regenerated so future decks inherit the same typeface without a quote-specific exception.

Constraint: The user requested a single Pretendard family across the deck.
Rejected: Retain the serif treatment for direct quotations | it breaks the requested single-family system.
Confidence: high
Scope-risk: narrow
Reversibility: clean
Directive: Preserve Pretendard as the only visible Korean typeface unless the user explicitly requests a different family.
Tested: All template slides rendered; overflow checks passed; package dry-run and card-news validator self-test passed.
Not-tested: Rendering on a device without Pretendard installed.
</commit_message>
<xml_diff>
--- a/.agents/skills/presentation-writing/assets/editorial-presentation-template.pptx
+++ b/.agents/skills/presentation-writing/assets/editorial-presentation-template.pptx
@@ -2,17 +2,17 @@
 <file path=ppt/presentation.xml><?xml version="1.0" encoding="utf-8"?>
 <p:presentation xmlns:p="http://schemas.openxmlformats.org/presentationml/2006/main">
   <p:sldMasterIdLst>
-    <p:sldMasterId xmlns:r="http://schemas.openxmlformats.org/officeDocument/2006/relationships" id="2147483648" r:id="Rfeae7a6932204da8"/>
+    <p:sldMasterId xmlns:r="http://schemas.openxmlformats.org/officeDocument/2006/relationships" id="2147483648" r:id="R524489bbdd764d6d"/>
   </p:sldMasterIdLst>
   <p:notesMasterIdLst>
-    <p:notesMasterId xmlns:r="http://schemas.openxmlformats.org/officeDocument/2006/relationships" r:id="R5143a90b87e54581"/>
+    <p:notesMasterId xmlns:r="http://schemas.openxmlformats.org/officeDocument/2006/relationships" r:id="R73cdaeb6bacc4053"/>
   </p:notesMasterIdLst>
   <p:sldIdLst>
-    <p:sldId xmlns:r="http://schemas.openxmlformats.org/officeDocument/2006/relationships" id="256" r:id="R90438b6e300144c1"/>
-    <p:sldId xmlns:r="http://schemas.openxmlformats.org/officeDocument/2006/relationships" id="257" r:id="Rde4ed9e34a3941f6"/>
-    <p:sldId xmlns:r="http://schemas.openxmlformats.org/officeDocument/2006/relationships" id="258" r:id="Rddd5bce9f75f495b"/>
-    <p:sldId xmlns:r="http://schemas.openxmlformats.org/officeDocument/2006/relationships" id="259" r:id="R2fad3638c60d4dae"/>
-    <p:sldId xmlns:r="http://schemas.openxmlformats.org/officeDocument/2006/relationships" id="260" r:id="Rd75c173ecfbf4707"/>
+    <p:sldId xmlns:r="http://schemas.openxmlformats.org/officeDocument/2006/relationships" id="256" r:id="Rfd5c1c06b554451b"/>
+    <p:sldId xmlns:r="http://schemas.openxmlformats.org/officeDocument/2006/relationships" id="257" r:id="R6ef1c8126e1a47ce"/>
+    <p:sldId xmlns:r="http://schemas.openxmlformats.org/officeDocument/2006/relationships" id="258" r:id="Rbdb4f5e28e2447fd"/>
+    <p:sldId xmlns:r="http://schemas.openxmlformats.org/officeDocument/2006/relationships" id="259" r:id="R35006bdc4bb5415c"/>
+    <p:sldId xmlns:r="http://schemas.openxmlformats.org/officeDocument/2006/relationships" id="260" r:id="R7a74a065b8424071"/>
   </p:sldIdLst>
   <p:sldSz cx="15240000" cy="8572500"/>
   <p:notesSz cx="6858000" cy="9144000"/>
@@ -844,7 +844,7 @@
   </p:cSld>
   <p:clrMap bg1="lt1" tx1="dk1" bg2="lt2" tx2="dk2" accent1="accent1" accent2="accent2" accent3="accent3" accent4="accent4" accent5="accent5" accent6="accent6" hlink="hlink" folHlink="folHlink"/>
   <p:sldLayoutIdLst>
-    <p:sldLayoutId xmlns:r="http://schemas.openxmlformats.org/officeDocument/2006/relationships" id="2147483649" r:id="Rcc8fc4b2eabd4415"/>
+    <p:sldLayoutId xmlns:r="http://schemas.openxmlformats.org/officeDocument/2006/relationships" id="2147483649" r:id="R3c04ae6b96c94bc1"/>
   </p:sldLayoutIdLst>
   <p:txStyles>
     <p:titleStyle>
@@ -1395,7 +1395,7 @@
           <p:cNvPr id="5" name="image-placeholder-opening">
             <a:extLst xmlns:a="http://schemas.openxmlformats.org/drawingml/2006/main">
               <a:ext uri="{FF2B5EF4-FFF2-40B4-BE49-F238E27FC236}">
-                <a16:creationId xmlns:a16="http://schemas.microsoft.com/office/drawing/2014/main" id="{4A142D94-1030-49FF-B532-8BB3C23F81DF}"/>
+                <a16:creationId xmlns:a16="http://schemas.microsoft.com/office/drawing/2014/main" id="{80DE6072-F494-4C00-ABA5-5156F17D6633}"/>
               </a:ext>
             </a:extLst>
           </p:cNvPr>
@@ -1428,7 +1428,7 @@
           <p:cNvPr id="2" name="image-placeholder-opening-label">
             <a:extLst xmlns:a="http://schemas.openxmlformats.org/drawingml/2006/main">
               <a:ext uri="{FF2B5EF4-FFF2-40B4-BE49-F238E27FC236}">
-                <a16:creationId xmlns:a16="http://schemas.microsoft.com/office/drawing/2014/main" id="{6B85D1DE-28F7-4A73-8BA7-19460EE31AE7}"/>
+                <a16:creationId xmlns:a16="http://schemas.microsoft.com/office/drawing/2014/main" id="{8391EC55-D497-4DA7-A8C9-07D7065E802A}"/>
               </a:ext>
             </a:extLst>
           </p:cNvPr>
@@ -1478,7 +1478,7 @@
           <p:cNvPr id="3" name="opening-title">
             <a:extLst xmlns:a="http://schemas.openxmlformats.org/drawingml/2006/main">
               <a:ext uri="{FF2B5EF4-FFF2-40B4-BE49-F238E27FC236}">
-                <a16:creationId xmlns:a16="http://schemas.microsoft.com/office/drawing/2014/main" id="{6B92C416-9EC0-4CED-934F-D3A3058086A5}"/>
+                <a16:creationId xmlns:a16="http://schemas.microsoft.com/office/drawing/2014/main" id="{BEA2F6C1-E074-4DB0-B104-242FD67E3EC8}"/>
               </a:ext>
             </a:extLst>
           </p:cNvPr>
@@ -1545,7 +1545,7 @@
           <p:cNvPr id="4" name="opening-body">
             <a:extLst xmlns:a="http://schemas.openxmlformats.org/drawingml/2006/main">
               <a:ext uri="{FF2B5EF4-FFF2-40B4-BE49-F238E27FC236}">
-                <a16:creationId xmlns:a16="http://schemas.microsoft.com/office/drawing/2014/main" id="{C061EB00-1144-4DB1-AC73-B33CFAB8521B}"/>
+                <a16:creationId xmlns:a16="http://schemas.microsoft.com/office/drawing/2014/main" id="{8AF89D06-2E92-4315-8AA0-F30934EE4EBD}"/>
               </a:ext>
             </a:extLst>
           </p:cNvPr>
@@ -1593,7 +1593,7 @@
     </p:spTree>
     <p:extLst>
       <p:ext uri="{BB962C8B-B14F-4D97-AF65-F5344CB8AC3E}">
-        <p14:creationId xmlns:p14="http://schemas.microsoft.com/office/powerpoint/2010/main" val="613760288"/>
+        <p14:creationId xmlns:p14="http://schemas.microsoft.com/office/powerpoint/2010/main" val="778654568"/>
       </p:ext>
     </p:extLst>
   </p:cSld>
@@ -1624,7 +1624,7 @@
           <p:cNvPr id="6" name="text-image-title">
             <a:extLst xmlns:a="http://schemas.openxmlformats.org/drawingml/2006/main">
               <a:ext uri="{FF2B5EF4-FFF2-40B4-BE49-F238E27FC236}">
-                <a16:creationId xmlns:a16="http://schemas.microsoft.com/office/drawing/2014/main" id="{AAA25A23-8F7C-4C28-B784-30A258685AED}"/>
+                <a16:creationId xmlns:a16="http://schemas.microsoft.com/office/drawing/2014/main" id="{77A75CD9-1F30-4BFF-8B6D-F96955498DB1}"/>
               </a:ext>
             </a:extLst>
           </p:cNvPr>
@@ -1691,7 +1691,7 @@
           <p:cNvPr id="2" name="text-image-body">
             <a:extLst xmlns:a="http://schemas.openxmlformats.org/drawingml/2006/main">
               <a:ext uri="{FF2B5EF4-FFF2-40B4-BE49-F238E27FC236}">
-                <a16:creationId xmlns:a16="http://schemas.microsoft.com/office/drawing/2014/main" id="{62AC02C7-C621-466E-98CA-1B79C8AEF9C8}"/>
+                <a16:creationId xmlns:a16="http://schemas.microsoft.com/office/drawing/2014/main" id="{B98E5E72-EC45-4A6D-A66B-2390A889D432}"/>
               </a:ext>
             </a:extLst>
           </p:cNvPr>
@@ -1780,7 +1780,7 @@
           <p:cNvPr id="3" name="image-placeholder-text-image">
             <a:extLst xmlns:a="http://schemas.openxmlformats.org/drawingml/2006/main">
               <a:ext uri="{FF2B5EF4-FFF2-40B4-BE49-F238E27FC236}">
-                <a16:creationId xmlns:a16="http://schemas.microsoft.com/office/drawing/2014/main" id="{DC682DC3-2953-4476-9CAC-F06283F7EF9D}"/>
+                <a16:creationId xmlns:a16="http://schemas.microsoft.com/office/drawing/2014/main" id="{5C5699F8-599A-4328-B2C6-7E3B9A8C1A10}"/>
               </a:ext>
             </a:extLst>
           </p:cNvPr>
@@ -1813,7 +1813,7 @@
           <p:cNvPr id="4" name="image-placeholder-text-image-label">
             <a:extLst xmlns:a="http://schemas.openxmlformats.org/drawingml/2006/main">
               <a:ext uri="{FF2B5EF4-FFF2-40B4-BE49-F238E27FC236}">
-                <a16:creationId xmlns:a16="http://schemas.microsoft.com/office/drawing/2014/main" id="{AC125B5D-5704-43B5-A28B-EC28E7BB0DC1}"/>
+                <a16:creationId xmlns:a16="http://schemas.microsoft.com/office/drawing/2014/main" id="{4399F813-B614-4A7B-8517-BCF8D86C8BEB}"/>
               </a:ext>
             </a:extLst>
           </p:cNvPr>
@@ -1863,7 +1863,7 @@
           <p:cNvPr id="5" name="source-line">
             <a:extLst xmlns:a="http://schemas.openxmlformats.org/drawingml/2006/main">
               <a:ext uri="{FF2B5EF4-FFF2-40B4-BE49-F238E27FC236}">
-                <a16:creationId xmlns:a16="http://schemas.microsoft.com/office/drawing/2014/main" id="{7D23B7FF-C27C-4410-9986-D7933D1B8269}"/>
+                <a16:creationId xmlns:a16="http://schemas.microsoft.com/office/drawing/2014/main" id="{A6E50583-48AF-42B8-BF7D-5B590FC5B253}"/>
               </a:ext>
             </a:extLst>
           </p:cNvPr>
@@ -1911,7 +1911,7 @@
     </p:spTree>
     <p:extLst>
       <p:ext uri="{BB962C8B-B14F-4D97-AF65-F5344CB8AC3E}">
-        <p14:creationId xmlns:p14="http://schemas.microsoft.com/office/powerpoint/2010/main" val="1303850270"/>
+        <p14:creationId xmlns:p14="http://schemas.microsoft.com/office/powerpoint/2010/main" val="139566606"/>
       </p:ext>
     </p:extLst>
   </p:cSld>
@@ -1942,7 +1942,7 @@
           <p:cNvPr id="6" name="image-placeholder-image-text">
             <a:extLst xmlns:a="http://schemas.openxmlformats.org/drawingml/2006/main">
               <a:ext uri="{FF2B5EF4-FFF2-40B4-BE49-F238E27FC236}">
-                <a16:creationId xmlns:a16="http://schemas.microsoft.com/office/drawing/2014/main" id="{30E82EE5-5A55-4C42-9B12-C1867BBE4723}"/>
+                <a16:creationId xmlns:a16="http://schemas.microsoft.com/office/drawing/2014/main" id="{B143B0DC-AEAC-4FF3-8A5F-64469D06845E}"/>
               </a:ext>
             </a:extLst>
           </p:cNvPr>
@@ -1975,7 +1975,7 @@
           <p:cNvPr id="2" name="image-placeholder-image-text-label">
             <a:extLst xmlns:a="http://schemas.openxmlformats.org/drawingml/2006/main">
               <a:ext uri="{FF2B5EF4-FFF2-40B4-BE49-F238E27FC236}">
-                <a16:creationId xmlns:a16="http://schemas.microsoft.com/office/drawing/2014/main" id="{C474DD5E-3F91-4DE6-9287-205EF9EC7BE9}"/>
+                <a16:creationId xmlns:a16="http://schemas.microsoft.com/office/drawing/2014/main" id="{C9F7BB6B-5A6E-4D02-9E12-DE0586EAA308}"/>
               </a:ext>
             </a:extLst>
           </p:cNvPr>
@@ -2025,7 +2025,7 @@
           <p:cNvPr id="3" name="image-text-title">
             <a:extLst xmlns:a="http://schemas.openxmlformats.org/drawingml/2006/main">
               <a:ext uri="{FF2B5EF4-FFF2-40B4-BE49-F238E27FC236}">
-                <a16:creationId xmlns:a16="http://schemas.microsoft.com/office/drawing/2014/main" id="{35BF4BB0-F959-4DAE-8AFC-92596F08A4A1}"/>
+                <a16:creationId xmlns:a16="http://schemas.microsoft.com/office/drawing/2014/main" id="{21099E8F-B773-4012-A592-5F7C210DB093}"/>
               </a:ext>
             </a:extLst>
           </p:cNvPr>
@@ -2092,7 +2092,7 @@
           <p:cNvPr id="4" name="image-text-body">
             <a:extLst xmlns:a="http://schemas.openxmlformats.org/drawingml/2006/main">
               <a:ext uri="{FF2B5EF4-FFF2-40B4-BE49-F238E27FC236}">
-                <a16:creationId xmlns:a16="http://schemas.microsoft.com/office/drawing/2014/main" id="{E27F7B35-9037-484A-A568-25238E82C3B2}"/>
+                <a16:creationId xmlns:a16="http://schemas.microsoft.com/office/drawing/2014/main" id="{C6C529AD-F3B7-4752-A3FE-CFB618639BAD}"/>
               </a:ext>
             </a:extLst>
           </p:cNvPr>
@@ -2198,7 +2198,7 @@
           <p:cNvPr id="5" name="source-line">
             <a:extLst xmlns:a="http://schemas.openxmlformats.org/drawingml/2006/main">
               <a:ext uri="{FF2B5EF4-FFF2-40B4-BE49-F238E27FC236}">
-                <a16:creationId xmlns:a16="http://schemas.microsoft.com/office/drawing/2014/main" id="{880D11D1-E597-4C4E-80E4-F9EAA45118D6}"/>
+                <a16:creationId xmlns:a16="http://schemas.microsoft.com/office/drawing/2014/main" id="{F3E19FC2-8758-4042-B0AC-16E982609C79}"/>
               </a:ext>
             </a:extLst>
           </p:cNvPr>
@@ -2246,7 +2246,7 @@
     </p:spTree>
     <p:extLst>
       <p:ext uri="{BB962C8B-B14F-4D97-AF65-F5344CB8AC3E}">
-        <p14:creationId xmlns:p14="http://schemas.microsoft.com/office/powerpoint/2010/main" val="1977502521"/>
+        <p14:creationId xmlns:p14="http://schemas.microsoft.com/office/powerpoint/2010/main" val="1238870239"/>
       </p:ext>
     </p:extLst>
   </p:cSld>
@@ -2277,7 +2277,7 @@
           <p:cNvPr id="5" name="quote-text">
             <a:extLst xmlns:a="http://schemas.openxmlformats.org/drawingml/2006/main">
               <a:ext uri="{FF2B5EF4-FFF2-40B4-BE49-F238E27FC236}">
-                <a16:creationId xmlns:a16="http://schemas.microsoft.com/office/drawing/2014/main" id="{04D0F9A3-0E74-4613-A563-79623B51B389}"/>
+                <a16:creationId xmlns:a16="http://schemas.microsoft.com/office/drawing/2014/main" id="{F98E9EF9-2C72-491F-93FF-1CF35BE2EE8D}"/>
               </a:ext>
             </a:extLst>
           </p:cNvPr>
@@ -2344,7 +2344,7 @@
           <p:cNvPr id="2" name="image-placeholder-quote">
             <a:extLst xmlns:a="http://schemas.openxmlformats.org/drawingml/2006/main">
               <a:ext uri="{FF2B5EF4-FFF2-40B4-BE49-F238E27FC236}">
-                <a16:creationId xmlns:a16="http://schemas.microsoft.com/office/drawing/2014/main" id="{1120A0A0-C98F-4DFF-B215-27286D4190ED}"/>
+                <a16:creationId xmlns:a16="http://schemas.microsoft.com/office/drawing/2014/main" id="{A31099DC-C13B-4F81-AB9D-B10E6DBC79CA}"/>
               </a:ext>
             </a:extLst>
           </p:cNvPr>
@@ -2377,7 +2377,7 @@
           <p:cNvPr id="3" name="image-placeholder-quote-label">
             <a:extLst xmlns:a="http://schemas.openxmlformats.org/drawingml/2006/main">
               <a:ext uri="{FF2B5EF4-FFF2-40B4-BE49-F238E27FC236}">
-                <a16:creationId xmlns:a16="http://schemas.microsoft.com/office/drawing/2014/main" id="{F828741C-F6DB-4E87-BEE8-43B5C4EED349}"/>
+                <a16:creationId xmlns:a16="http://schemas.microsoft.com/office/drawing/2014/main" id="{09160B45-90D2-4A0C-B9D7-F550717D8E6B}"/>
               </a:ext>
             </a:extLst>
           </p:cNvPr>
@@ -2427,7 +2427,7 @@
           <p:cNvPr id="4" name="source-line">
             <a:extLst xmlns:a="http://schemas.openxmlformats.org/drawingml/2006/main">
               <a:ext uri="{FF2B5EF4-FFF2-40B4-BE49-F238E27FC236}">
-                <a16:creationId xmlns:a16="http://schemas.microsoft.com/office/drawing/2014/main" id="{4D01C044-BDC5-44DB-8B74-848019DA4F9D}"/>
+                <a16:creationId xmlns:a16="http://schemas.microsoft.com/office/drawing/2014/main" id="{66D583E5-7591-417B-AA77-C2EF5AF4E069}"/>
               </a:ext>
             </a:extLst>
           </p:cNvPr>
@@ -2475,7 +2475,7 @@
     </p:spTree>
     <p:extLst>
       <p:ext uri="{BB962C8B-B14F-4D97-AF65-F5344CB8AC3E}">
-        <p14:creationId xmlns:p14="http://schemas.microsoft.com/office/powerpoint/2010/main" val="1200892671"/>
+        <p14:creationId xmlns:p14="http://schemas.microsoft.com/office/powerpoint/2010/main" val="147211154"/>
       </p:ext>
     </p:extLst>
   </p:cSld>
@@ -2506,7 +2506,7 @@
           <p:cNvPr id="3" name="close-title">
             <a:extLst xmlns:a="http://schemas.openxmlformats.org/drawingml/2006/main">
               <a:ext uri="{FF2B5EF4-FFF2-40B4-BE49-F238E27FC236}">
-                <a16:creationId xmlns:a16="http://schemas.microsoft.com/office/drawing/2014/main" id="{2EC3186B-5A9A-4297-9705-72FF66672681}"/>
+                <a16:creationId xmlns:a16="http://schemas.microsoft.com/office/drawing/2014/main" id="{A65CEFBF-CF27-41D5-B8C0-C47468078D89}"/>
               </a:ext>
             </a:extLst>
           </p:cNvPr>
@@ -2573,7 +2573,7 @@
           <p:cNvPr id="2" name="close-body">
             <a:extLst xmlns:a="http://schemas.openxmlformats.org/drawingml/2006/main">
               <a:ext uri="{FF2B5EF4-FFF2-40B4-BE49-F238E27FC236}">
-                <a16:creationId xmlns:a16="http://schemas.microsoft.com/office/drawing/2014/main" id="{BF23285A-7B13-4D05-AD39-9C3840A75D94}"/>
+                <a16:creationId xmlns:a16="http://schemas.microsoft.com/office/drawing/2014/main" id="{744BBBD8-FC78-4FAD-BD81-B01522577425}"/>
               </a:ext>
             </a:extLst>
           </p:cNvPr>
@@ -2638,7 +2638,7 @@
     </p:spTree>
     <p:extLst>
       <p:ext uri="{BB962C8B-B14F-4D97-AF65-F5344CB8AC3E}">
-        <p14:creationId xmlns:p14="http://schemas.microsoft.com/office/powerpoint/2010/main" val="99974767"/>
+        <p14:creationId xmlns:p14="http://schemas.microsoft.com/office/powerpoint/2010/main" val="1894527331"/>
       </p:ext>
     </p:extLst>
   </p:cSld>

</xml_diff>

<commit_message>
Embed Pretendard in presentation themes
The presentation generator used an unsupported text style key, which left the PowerPoint theme set to Calibri despite the intended visual direction. It now assigns Pretendard to individual text runs and the document theme, so editable slides retain the chosen Korean font.

Constraint: PowerPoint inherits Calibri when explicit text and theme typefaces are absent
Rejected: Rely on application defaults or rendered appearance alone | PowerPoint's font controls still exposed Calibri
Confidence: high
Scope-risk: narrow
Reversibility: clean
Directive: Keep direct text typeface and theme fonts synchronized in generated decks
Tested: XML verification of both template and example; slide render; overflow check; npm test; npm run pack:check
Not-tested: Manual opening in Microsoft PowerPoint
</commit_message>
<xml_diff>
--- a/.agents/skills/presentation-writing/assets/editorial-presentation-template.pptx
+++ b/.agents/skills/presentation-writing/assets/editorial-presentation-template.pptx
@@ -2,17 +2,17 @@
 <file path=ppt/presentation.xml><?xml version="1.0" encoding="utf-8"?>
 <p:presentation xmlns:p="http://schemas.openxmlformats.org/presentationml/2006/main">
   <p:sldMasterIdLst>
-    <p:sldMasterId xmlns:r="http://schemas.openxmlformats.org/officeDocument/2006/relationships" id="2147483648" r:id="R524489bbdd764d6d"/>
+    <p:sldMasterId xmlns:r="http://schemas.openxmlformats.org/officeDocument/2006/relationships" id="2147483648" r:id="Rd076af2aa61a4700"/>
   </p:sldMasterIdLst>
   <p:notesMasterIdLst>
-    <p:notesMasterId xmlns:r="http://schemas.openxmlformats.org/officeDocument/2006/relationships" r:id="R73cdaeb6bacc4053"/>
+    <p:notesMasterId xmlns:r="http://schemas.openxmlformats.org/officeDocument/2006/relationships" r:id="Reb5bc9b636fb40ef"/>
   </p:notesMasterIdLst>
   <p:sldIdLst>
-    <p:sldId xmlns:r="http://schemas.openxmlformats.org/officeDocument/2006/relationships" id="256" r:id="Rfd5c1c06b554451b"/>
-    <p:sldId xmlns:r="http://schemas.openxmlformats.org/officeDocument/2006/relationships" id="257" r:id="R6ef1c8126e1a47ce"/>
-    <p:sldId xmlns:r="http://schemas.openxmlformats.org/officeDocument/2006/relationships" id="258" r:id="Rbdb4f5e28e2447fd"/>
-    <p:sldId xmlns:r="http://schemas.openxmlformats.org/officeDocument/2006/relationships" id="259" r:id="R35006bdc4bb5415c"/>
-    <p:sldId xmlns:r="http://schemas.openxmlformats.org/officeDocument/2006/relationships" id="260" r:id="R7a74a065b8424071"/>
+    <p:sldId xmlns:r="http://schemas.openxmlformats.org/officeDocument/2006/relationships" id="256" r:id="R34db0b90f05245df"/>
+    <p:sldId xmlns:r="http://schemas.openxmlformats.org/officeDocument/2006/relationships" id="257" r:id="Rfcd1d45210a34a41"/>
+    <p:sldId xmlns:r="http://schemas.openxmlformats.org/officeDocument/2006/relationships" id="258" r:id="R5a5f7a9ffa114ff3"/>
+    <p:sldId xmlns:r="http://schemas.openxmlformats.org/officeDocument/2006/relationships" id="259" r:id="R3d99435367f64068"/>
+    <p:sldId xmlns:r="http://schemas.openxmlformats.org/officeDocument/2006/relationships" id="260" r:id="R3ceb181667ba4165"/>
   </p:sldIdLst>
   <p:sldSz cx="15240000" cy="8572500"/>
   <p:notesSz cx="6858000" cy="9144000"/>
@@ -844,7 +844,7 @@
   </p:cSld>
   <p:clrMap bg1="lt1" tx1="dk1" bg2="lt2" tx2="dk2" accent1="accent1" accent2="accent2" accent3="accent3" accent4="accent4" accent5="accent5" accent6="accent6" hlink="hlink" folHlink="folHlink"/>
   <p:sldLayoutIdLst>
-    <p:sldLayoutId xmlns:r="http://schemas.openxmlformats.org/officeDocument/2006/relationships" id="2147483649" r:id="R3c04ae6b96c94bc1"/>
+    <p:sldLayoutId xmlns:r="http://schemas.openxmlformats.org/officeDocument/2006/relationships" id="2147483649" r:id="Rb17c29a4e4c6434d"/>
   </p:sldLayoutIdLst>
   <p:txStyles>
     <p:titleStyle>
@@ -1395,7 +1395,7 @@
           <p:cNvPr id="5" name="image-placeholder-opening">
             <a:extLst xmlns:a="http://schemas.openxmlformats.org/drawingml/2006/main">
               <a:ext uri="{FF2B5EF4-FFF2-40B4-BE49-F238E27FC236}">
-                <a16:creationId xmlns:a16="http://schemas.microsoft.com/office/drawing/2014/main" id="{80DE6072-F494-4C00-ABA5-5156F17D6633}"/>
+                <a16:creationId xmlns:a16="http://schemas.microsoft.com/office/drawing/2014/main" id="{9A3C3709-DF34-420D-945B-013E8B433137}"/>
               </a:ext>
             </a:extLst>
           </p:cNvPr>
@@ -1428,7 +1428,7 @@
           <p:cNvPr id="2" name="image-placeholder-opening-label">
             <a:extLst xmlns:a="http://schemas.openxmlformats.org/drawingml/2006/main">
               <a:ext uri="{FF2B5EF4-FFF2-40B4-BE49-F238E27FC236}">
-                <a16:creationId xmlns:a16="http://schemas.microsoft.com/office/drawing/2014/main" id="{8391EC55-D497-4DA7-A8C9-07D7065E802A}"/>
+                <a16:creationId xmlns:a16="http://schemas.microsoft.com/office/drawing/2014/main" id="{BB59E90D-64F9-4142-B891-46EB3CC8AEC9}"/>
               </a:ext>
             </a:extLst>
           </p:cNvPr>
@@ -1460,6 +1460,9 @@
                 <a:solidFill>
                   <a:srgbClr val="555555"/>
                 </a:solidFill>
+                <a:latin typeface="Pretendard"/>
+                <a:ea typeface="Pretendard"/>
+                <a:cs typeface="Pretendard"/>
               </a:defRPr>
             </a:pPr>
             <a:r>
@@ -1467,6 +1470,9 @@
                 <a:solidFill>
                   <a:srgbClr val="555555"/>
                 </a:solidFill>
+                <a:latin typeface="Pretendard"/>
+                <a:ea typeface="Pretendard"/>
+                <a:cs typeface="Pretendard"/>
               </a:rPr>
               <a:t>사진: 인물·현장·물건 중 하나 · 세로</a:t>
             </a:r>
@@ -1478,7 +1484,7 @@
           <p:cNvPr id="3" name="opening-title">
             <a:extLst xmlns:a="http://schemas.openxmlformats.org/drawingml/2006/main">
               <a:ext uri="{FF2B5EF4-FFF2-40B4-BE49-F238E27FC236}">
-                <a16:creationId xmlns:a16="http://schemas.microsoft.com/office/drawing/2014/main" id="{BEA2F6C1-E074-4DB0-B104-242FD67E3EC8}"/>
+                <a16:creationId xmlns:a16="http://schemas.microsoft.com/office/drawing/2014/main" id="{16F9DC67-3C9C-4435-AF43-F92CCE2B89C5}"/>
               </a:ext>
             </a:extLst>
           </p:cNvPr>
@@ -1510,6 +1516,9 @@
                 <a:solidFill>
                   <a:srgbClr val="111111"/>
                 </a:solidFill>
+                <a:latin typeface="Pretendard"/>
+                <a:ea typeface="Pretendard"/>
+                <a:cs typeface="Pretendard"/>
               </a:defRPr>
             </a:pPr>
             <a:r>
@@ -1517,6 +1526,9 @@
                 <a:solidFill>
                   <a:srgbClr val="111111"/>
                 </a:solidFill>
+                <a:latin typeface="Pretendard"/>
+                <a:ea typeface="Pretendard"/>
+                <a:cs typeface="Pretendard"/>
               </a:rPr>
               <a:t>제목을 한 문장으로</a:t>
             </a:r>
@@ -1527,6 +1539,9 @@
                 <a:solidFill>
                   <a:srgbClr val="111111"/>
                 </a:solidFill>
+                <a:latin typeface="Pretendard"/>
+                <a:ea typeface="Pretendard"/>
+                <a:cs typeface="Pretendard"/>
               </a:defRPr>
             </a:pPr>
             <a:r>
@@ -1534,6 +1549,9 @@
                 <a:solidFill>
                   <a:srgbClr val="111111"/>
                 </a:solidFill>
+                <a:latin typeface="Pretendard"/>
+                <a:ea typeface="Pretendard"/>
+                <a:cs typeface="Pretendard"/>
               </a:rPr>
               <a:t>말합니다</a:t>
             </a:r>
@@ -1545,7 +1563,7 @@
           <p:cNvPr id="4" name="opening-body">
             <a:extLst xmlns:a="http://schemas.openxmlformats.org/drawingml/2006/main">
               <a:ext uri="{FF2B5EF4-FFF2-40B4-BE49-F238E27FC236}">
-                <a16:creationId xmlns:a16="http://schemas.microsoft.com/office/drawing/2014/main" id="{8AF89D06-2E92-4315-8AA0-F30934EE4EBD}"/>
+                <a16:creationId xmlns:a16="http://schemas.microsoft.com/office/drawing/2014/main" id="{994969ED-F5C6-40CB-BC7C-DE9F4523FA8C}"/>
               </a:ext>
             </a:extLst>
           </p:cNvPr>
@@ -1577,6 +1595,9 @@
                 <a:solidFill>
                   <a:srgbClr val="3D3D3D"/>
                 </a:solidFill>
+                <a:latin typeface="Pretendard"/>
+                <a:ea typeface="Pretendard"/>
+                <a:cs typeface="Pretendard"/>
               </a:defRPr>
             </a:pPr>
             <a:r>
@@ -1584,6 +1605,9 @@
                 <a:solidFill>
                   <a:srgbClr val="3D3D3D"/>
                 </a:solidFill>
+                <a:latin typeface="Pretendard"/>
+                <a:ea typeface="Pretendard"/>
+                <a:cs typeface="Pretendard"/>
               </a:rPr>
               <a:t>발표가 끝난 뒤 청중이 기억할 핵심을 짧게 적습니다.</a:t>
             </a:r>
@@ -1593,7 +1617,7 @@
     </p:spTree>
     <p:extLst>
       <p:ext uri="{BB962C8B-B14F-4D97-AF65-F5344CB8AC3E}">
-        <p14:creationId xmlns:p14="http://schemas.microsoft.com/office/powerpoint/2010/main" val="778654568"/>
+        <p14:creationId xmlns:p14="http://schemas.microsoft.com/office/powerpoint/2010/main" val="1046490327"/>
       </p:ext>
     </p:extLst>
   </p:cSld>
@@ -1624,7 +1648,7 @@
           <p:cNvPr id="6" name="text-image-title">
             <a:extLst xmlns:a="http://schemas.openxmlformats.org/drawingml/2006/main">
               <a:ext uri="{FF2B5EF4-FFF2-40B4-BE49-F238E27FC236}">
-                <a16:creationId xmlns:a16="http://schemas.microsoft.com/office/drawing/2014/main" id="{77A75CD9-1F30-4BFF-8B6D-F96955498DB1}"/>
+                <a16:creationId xmlns:a16="http://schemas.microsoft.com/office/drawing/2014/main" id="{FDCF6A2D-7475-4ACE-9C25-64D74D7992B2}"/>
               </a:ext>
             </a:extLst>
           </p:cNvPr>
@@ -1656,6 +1680,9 @@
                 <a:solidFill>
                   <a:srgbClr val="111111"/>
                 </a:solidFill>
+                <a:latin typeface="Pretendard"/>
+                <a:ea typeface="Pretendard"/>
+                <a:cs typeface="Pretendard"/>
               </a:defRPr>
             </a:pPr>
             <a:r>
@@ -1663,6 +1690,9 @@
                 <a:solidFill>
                   <a:srgbClr val="111111"/>
                 </a:solidFill>
+                <a:latin typeface="Pretendard"/>
+                <a:ea typeface="Pretendard"/>
+                <a:cs typeface="Pretendard"/>
               </a:rPr>
               <a:t>설명은 먼저,</a:t>
             </a:r>
@@ -1673,6 +1703,9 @@
                 <a:solidFill>
                   <a:srgbClr val="111111"/>
                 </a:solidFill>
+                <a:latin typeface="Pretendard"/>
+                <a:ea typeface="Pretendard"/>
+                <a:cs typeface="Pretendard"/>
               </a:defRPr>
             </a:pPr>
             <a:r>
@@ -1680,6 +1713,9 @@
                 <a:solidFill>
                   <a:srgbClr val="111111"/>
                 </a:solidFill>
+                <a:latin typeface="Pretendard"/>
+                <a:ea typeface="Pretendard"/>
+                <a:cs typeface="Pretendard"/>
               </a:rPr>
               <a:t>사진은 그다음 보게 합니다</a:t>
             </a:r>
@@ -1691,7 +1727,7 @@
           <p:cNvPr id="2" name="text-image-body">
             <a:extLst xmlns:a="http://schemas.openxmlformats.org/drawingml/2006/main">
               <a:ext uri="{FF2B5EF4-FFF2-40B4-BE49-F238E27FC236}">
-                <a16:creationId xmlns:a16="http://schemas.microsoft.com/office/drawing/2014/main" id="{B98E5E72-EC45-4A6D-A66B-2390A889D432}"/>
+                <a16:creationId xmlns:a16="http://schemas.microsoft.com/office/drawing/2014/main" id="{7FBE995E-2FD4-4306-92F5-D0A0BD5EF706}"/>
               </a:ext>
             </a:extLst>
           </p:cNvPr>
@@ -1723,6 +1759,9 @@
                 <a:solidFill>
                   <a:srgbClr val="333333"/>
                 </a:solidFill>
+                <a:latin typeface="Pretendard"/>
+                <a:ea typeface="Pretendard"/>
+                <a:cs typeface="Pretendard"/>
               </a:defRPr>
             </a:pPr>
             <a:r>
@@ -1730,6 +1769,9 @@
                 <a:solidFill>
                   <a:srgbClr val="333333"/>
                 </a:solidFill>
+                <a:latin typeface="Pretendard"/>
+                <a:ea typeface="Pretendard"/>
+                <a:cs typeface="Pretendard"/>
               </a:rPr>
               <a:t>맥락과 근거를 두세 문장으로 정리합니다.</a:t>
             </a:r>
@@ -1740,6 +1782,9 @@
                 <a:solidFill>
                   <a:srgbClr val="333333"/>
                 </a:solidFill>
+                <a:latin typeface="Pretendard"/>
+                <a:ea typeface="Pretendard"/>
+                <a:cs typeface="Pretendard"/>
               </a:defRPr>
             </a:pPr>
             <a:r>
@@ -1747,6 +1792,9 @@
                 <a:solidFill>
                   <a:srgbClr val="333333"/>
                 </a:solidFill>
+                <a:latin typeface="Pretendard"/>
+                <a:ea typeface="Pretendard"/>
+                <a:cs typeface="Pretendard"/>
               </a:rPr>
               <a:t>길어지면 다음 슬라이드로 넘깁니다.</a:t>
             </a:r>
@@ -1762,6 +1810,9 @@
                 <a:solidFill>
                   <a:srgbClr val="333333"/>
                 </a:solidFill>
+                <a:latin typeface="Pretendard"/>
+                <a:ea typeface="Pretendard"/>
+                <a:cs typeface="Pretendard"/>
               </a:defRPr>
             </a:pPr>
             <a:r>
@@ -1769,6 +1820,9 @@
                 <a:solidFill>
                   <a:srgbClr val="333333"/>
                 </a:solidFill>
+                <a:latin typeface="Pretendard"/>
+                <a:ea typeface="Pretendard"/>
+                <a:cs typeface="Pretendard"/>
               </a:rPr>
               <a:t>강조할 한 문장만 굵은 검정 밑줄로 처리합니다.</a:t>
             </a:r>
@@ -1780,7 +1834,7 @@
           <p:cNvPr id="3" name="image-placeholder-text-image">
             <a:extLst xmlns:a="http://schemas.openxmlformats.org/drawingml/2006/main">
               <a:ext uri="{FF2B5EF4-FFF2-40B4-BE49-F238E27FC236}">
-                <a16:creationId xmlns:a16="http://schemas.microsoft.com/office/drawing/2014/main" id="{5C5699F8-599A-4328-B2C6-7E3B9A8C1A10}"/>
+                <a16:creationId xmlns:a16="http://schemas.microsoft.com/office/drawing/2014/main" id="{CDC0686A-1EE2-48AB-A0E8-6A0B21AA1F57}"/>
               </a:ext>
             </a:extLst>
           </p:cNvPr>
@@ -1813,7 +1867,7 @@
           <p:cNvPr id="4" name="image-placeholder-text-image-label">
             <a:extLst xmlns:a="http://schemas.openxmlformats.org/drawingml/2006/main">
               <a:ext uri="{FF2B5EF4-FFF2-40B4-BE49-F238E27FC236}">
-                <a16:creationId xmlns:a16="http://schemas.microsoft.com/office/drawing/2014/main" id="{4399F813-B614-4A7B-8517-BCF8D86C8BEB}"/>
+                <a16:creationId xmlns:a16="http://schemas.microsoft.com/office/drawing/2014/main" id="{52E22398-DA67-4066-93A5-5056F5C9C2B5}"/>
               </a:ext>
             </a:extLst>
           </p:cNvPr>
@@ -1845,6 +1899,9 @@
                 <a:solidFill>
                   <a:srgbClr val="555555"/>
                 </a:solidFill>
+                <a:latin typeface="Pretendard"/>
+                <a:ea typeface="Pretendard"/>
+                <a:cs typeface="Pretendard"/>
               </a:defRPr>
             </a:pPr>
             <a:r>
@@ -1852,6 +1909,9 @@
                 <a:solidFill>
                   <a:srgbClr val="555555"/>
                 </a:solidFill>
+                <a:latin typeface="Pretendard"/>
+                <a:ea typeface="Pretendard"/>
+                <a:cs typeface="Pretendard"/>
               </a:rPr>
               <a:t>사진: 맥락을 보여주는 현장 · 가로</a:t>
             </a:r>
@@ -1863,7 +1923,7 @@
           <p:cNvPr id="5" name="source-line">
             <a:extLst xmlns:a="http://schemas.openxmlformats.org/drawingml/2006/main">
               <a:ext uri="{FF2B5EF4-FFF2-40B4-BE49-F238E27FC236}">
-                <a16:creationId xmlns:a16="http://schemas.microsoft.com/office/drawing/2014/main" id="{A6E50583-48AF-42B8-BF7D-5B590FC5B253}"/>
+                <a16:creationId xmlns:a16="http://schemas.microsoft.com/office/drawing/2014/main" id="{DBB874F2-83F5-4008-A3C5-7C0D293D5772}"/>
               </a:ext>
             </a:extLst>
           </p:cNvPr>
@@ -1895,6 +1955,9 @@
                 <a:solidFill>
                   <a:srgbClr val="666666"/>
                 </a:solidFill>
+                <a:latin typeface="Pretendard"/>
+                <a:ea typeface="Pretendard"/>
+                <a:cs typeface="Pretendard"/>
               </a:defRPr>
             </a:pPr>
             <a:r>
@@ -1902,6 +1965,9 @@
                 <a:solidFill>
                   <a:srgbClr val="666666"/>
                 </a:solidFill>
+                <a:latin typeface="Pretendard"/>
+                <a:ea typeface="Pretendard"/>
+                <a:cs typeface="Pretendard"/>
               </a:rPr>
               <a:t>출처: 최종 자료에서 확인</a:t>
             </a:r>
@@ -1911,7 +1977,7 @@
     </p:spTree>
     <p:extLst>
       <p:ext uri="{BB962C8B-B14F-4D97-AF65-F5344CB8AC3E}">
-        <p14:creationId xmlns:p14="http://schemas.microsoft.com/office/powerpoint/2010/main" val="139566606"/>
+        <p14:creationId xmlns:p14="http://schemas.microsoft.com/office/powerpoint/2010/main" val="1676862379"/>
       </p:ext>
     </p:extLst>
   </p:cSld>
@@ -1942,7 +2008,7 @@
           <p:cNvPr id="6" name="image-placeholder-image-text">
             <a:extLst xmlns:a="http://schemas.openxmlformats.org/drawingml/2006/main">
               <a:ext uri="{FF2B5EF4-FFF2-40B4-BE49-F238E27FC236}">
-                <a16:creationId xmlns:a16="http://schemas.microsoft.com/office/drawing/2014/main" id="{B143B0DC-AEAC-4FF3-8A5F-64469D06845E}"/>
+                <a16:creationId xmlns:a16="http://schemas.microsoft.com/office/drawing/2014/main" id="{F8FFE437-A2C8-40A6-86E2-ADDE43D4E826}"/>
               </a:ext>
             </a:extLst>
           </p:cNvPr>
@@ -1975,7 +2041,7 @@
           <p:cNvPr id="2" name="image-placeholder-image-text-label">
             <a:extLst xmlns:a="http://schemas.openxmlformats.org/drawingml/2006/main">
               <a:ext uri="{FF2B5EF4-FFF2-40B4-BE49-F238E27FC236}">
-                <a16:creationId xmlns:a16="http://schemas.microsoft.com/office/drawing/2014/main" id="{C9F7BB6B-5A6E-4D02-9E12-DE0586EAA308}"/>
+                <a16:creationId xmlns:a16="http://schemas.microsoft.com/office/drawing/2014/main" id="{826873E8-55F1-4BE9-9F88-32C61E561739}"/>
               </a:ext>
             </a:extLst>
           </p:cNvPr>
@@ -2007,6 +2073,9 @@
                 <a:solidFill>
                   <a:srgbClr val="555555"/>
                 </a:solidFill>
+                <a:latin typeface="Pretendard"/>
+                <a:ea typeface="Pretendard"/>
+                <a:cs typeface="Pretendard"/>
               </a:defRPr>
             </a:pPr>
             <a:r>
@@ -2014,6 +2083,9 @@
                 <a:solidFill>
                   <a:srgbClr val="555555"/>
                 </a:solidFill>
+                <a:latin typeface="Pretendard"/>
+                <a:ea typeface="Pretendard"/>
+                <a:cs typeface="Pretendard"/>
               </a:rPr>
               <a:t>사진: 감정을 만드는 인물 또는 현장 · 세로</a:t>
             </a:r>
@@ -2025,7 +2097,7 @@
           <p:cNvPr id="3" name="image-text-title">
             <a:extLst xmlns:a="http://schemas.openxmlformats.org/drawingml/2006/main">
               <a:ext uri="{FF2B5EF4-FFF2-40B4-BE49-F238E27FC236}">
-                <a16:creationId xmlns:a16="http://schemas.microsoft.com/office/drawing/2014/main" id="{21099E8F-B773-4012-A592-5F7C210DB093}"/>
+                <a16:creationId xmlns:a16="http://schemas.microsoft.com/office/drawing/2014/main" id="{A59070D6-465A-453E-92C8-C7299902DBA5}"/>
               </a:ext>
             </a:extLst>
           </p:cNvPr>
@@ -2057,6 +2129,9 @@
                 <a:solidFill>
                   <a:srgbClr val="111111"/>
                 </a:solidFill>
+                <a:latin typeface="Pretendard"/>
+                <a:ea typeface="Pretendard"/>
+                <a:cs typeface="Pretendard"/>
               </a:defRPr>
             </a:pPr>
             <a:r>
@@ -2064,6 +2139,9 @@
                 <a:solidFill>
                   <a:srgbClr val="111111"/>
                 </a:solidFill>
+                <a:latin typeface="Pretendard"/>
+                <a:ea typeface="Pretendard"/>
+                <a:cs typeface="Pretendard"/>
               </a:rPr>
               <a:t>사진이 먼저,</a:t>
             </a:r>
@@ -2074,6 +2152,9 @@
                 <a:solidFill>
                   <a:srgbClr val="111111"/>
                 </a:solidFill>
+                <a:latin typeface="Pretendard"/>
+                <a:ea typeface="Pretendard"/>
+                <a:cs typeface="Pretendard"/>
               </a:defRPr>
             </a:pPr>
             <a:r>
@@ -2081,6 +2162,9 @@
                 <a:solidFill>
                   <a:srgbClr val="111111"/>
                 </a:solidFill>
+                <a:latin typeface="Pretendard"/>
+                <a:ea typeface="Pretendard"/>
+                <a:cs typeface="Pretendard"/>
               </a:rPr>
               <a:t>맥락은 그다음 옵니다</a:t>
             </a:r>
@@ -2092,7 +2176,7 @@
           <p:cNvPr id="4" name="image-text-body">
             <a:extLst xmlns:a="http://schemas.openxmlformats.org/drawingml/2006/main">
               <a:ext uri="{FF2B5EF4-FFF2-40B4-BE49-F238E27FC236}">
-                <a16:creationId xmlns:a16="http://schemas.microsoft.com/office/drawing/2014/main" id="{C6C529AD-F3B7-4752-A3FE-CFB618639BAD}"/>
+                <a16:creationId xmlns:a16="http://schemas.microsoft.com/office/drawing/2014/main" id="{493651B2-7A91-49A2-9884-6C9C5D2AC589}"/>
               </a:ext>
             </a:extLst>
           </p:cNvPr>
@@ -2124,6 +2208,9 @@
                 <a:solidFill>
                   <a:srgbClr val="333333"/>
                 </a:solidFill>
+                <a:latin typeface="Pretendard"/>
+                <a:ea typeface="Pretendard"/>
+                <a:cs typeface="Pretendard"/>
               </a:defRPr>
             </a:pPr>
             <a:r>
@@ -2131,6 +2218,9 @@
                 <a:solidFill>
                   <a:srgbClr val="333333"/>
                 </a:solidFill>
+                <a:latin typeface="Pretendard"/>
+                <a:ea typeface="Pretendard"/>
+                <a:cs typeface="Pretendard"/>
               </a:rPr>
               <a:t>사진이 만든 첫 인상을</a:t>
             </a:r>
@@ -2141,6 +2231,9 @@
                 <a:solidFill>
                   <a:srgbClr val="333333"/>
                 </a:solidFill>
+                <a:latin typeface="Pretendard"/>
+                <a:ea typeface="Pretendard"/>
+                <a:cs typeface="Pretendard"/>
               </a:defRPr>
             </a:pPr>
             <a:r>
@@ -2148,6 +2241,9 @@
                 <a:solidFill>
                   <a:srgbClr val="333333"/>
                 </a:solidFill>
+                <a:latin typeface="Pretendard"/>
+                <a:ea typeface="Pretendard"/>
+                <a:cs typeface="Pretendard"/>
               </a:rPr>
               <a:t>짧은 설명으로 해석합니다.</a:t>
             </a:r>
@@ -2163,6 +2259,9 @@
                 <a:solidFill>
                   <a:srgbClr val="333333"/>
                 </a:solidFill>
+                <a:latin typeface="Pretendard"/>
+                <a:ea typeface="Pretendard"/>
+                <a:cs typeface="Pretendard"/>
               </a:defRPr>
             </a:pPr>
             <a:r>
@@ -2170,6 +2269,9 @@
                 <a:solidFill>
                   <a:srgbClr val="333333"/>
                 </a:solidFill>
+                <a:latin typeface="Pretendard"/>
+                <a:ea typeface="Pretendard"/>
+                <a:cs typeface="Pretendard"/>
               </a:rPr>
               <a:t>한 슬라이드에는 한 가지</a:t>
             </a:r>
@@ -2180,6 +2282,9 @@
                 <a:solidFill>
                   <a:srgbClr val="333333"/>
                 </a:solidFill>
+                <a:latin typeface="Pretendard"/>
+                <a:ea typeface="Pretendard"/>
+                <a:cs typeface="Pretendard"/>
               </a:defRPr>
             </a:pPr>
             <a:r>
@@ -2187,6 +2292,9 @@
                 <a:solidFill>
                   <a:srgbClr val="333333"/>
                 </a:solidFill>
+                <a:latin typeface="Pretendard"/>
+                <a:ea typeface="Pretendard"/>
+                <a:cs typeface="Pretendard"/>
               </a:rPr>
               <a:t>판단만 남깁니다.</a:t>
             </a:r>
@@ -2198,7 +2306,7 @@
           <p:cNvPr id="5" name="source-line">
             <a:extLst xmlns:a="http://schemas.openxmlformats.org/drawingml/2006/main">
               <a:ext uri="{FF2B5EF4-FFF2-40B4-BE49-F238E27FC236}">
-                <a16:creationId xmlns:a16="http://schemas.microsoft.com/office/drawing/2014/main" id="{F3E19FC2-8758-4042-B0AC-16E982609C79}"/>
+                <a16:creationId xmlns:a16="http://schemas.microsoft.com/office/drawing/2014/main" id="{DE715B30-29D5-4D36-9001-4440DB0CD0BF}"/>
               </a:ext>
             </a:extLst>
           </p:cNvPr>
@@ -2230,6 +2338,9 @@
                 <a:solidFill>
                   <a:srgbClr val="666666"/>
                 </a:solidFill>
+                <a:latin typeface="Pretendard"/>
+                <a:ea typeface="Pretendard"/>
+                <a:cs typeface="Pretendard"/>
               </a:defRPr>
             </a:pPr>
             <a:r>
@@ -2237,6 +2348,9 @@
                 <a:solidFill>
                   <a:srgbClr val="666666"/>
                 </a:solidFill>
+                <a:latin typeface="Pretendard"/>
+                <a:ea typeface="Pretendard"/>
+                <a:cs typeface="Pretendard"/>
               </a:rPr>
               <a:t>출처: 최종 자료에서 확인</a:t>
             </a:r>
@@ -2246,7 +2360,7 @@
     </p:spTree>
     <p:extLst>
       <p:ext uri="{BB962C8B-B14F-4D97-AF65-F5344CB8AC3E}">
-        <p14:creationId xmlns:p14="http://schemas.microsoft.com/office/powerpoint/2010/main" val="1238870239"/>
+        <p14:creationId xmlns:p14="http://schemas.microsoft.com/office/powerpoint/2010/main" val="1484250379"/>
       </p:ext>
     </p:extLst>
   </p:cSld>
@@ -2277,7 +2391,7 @@
           <p:cNvPr id="5" name="quote-text">
             <a:extLst xmlns:a="http://schemas.openxmlformats.org/drawingml/2006/main">
               <a:ext uri="{FF2B5EF4-FFF2-40B4-BE49-F238E27FC236}">
-                <a16:creationId xmlns:a16="http://schemas.microsoft.com/office/drawing/2014/main" id="{F98E9EF9-2C72-491F-93FF-1CF35BE2EE8D}"/>
+                <a16:creationId xmlns:a16="http://schemas.microsoft.com/office/drawing/2014/main" id="{384DF323-6F1E-4AEB-8A35-4B00D629A662}"/>
               </a:ext>
             </a:extLst>
           </p:cNvPr>
@@ -2309,6 +2423,9 @@
                 <a:solidFill>
                   <a:srgbClr val="111111"/>
                 </a:solidFill>
+                <a:latin typeface="Pretendard"/>
+                <a:ea typeface="Pretendard"/>
+                <a:cs typeface="Pretendard"/>
               </a:defRPr>
             </a:pPr>
             <a:r>
@@ -2316,6 +2433,9 @@
                 <a:solidFill>
                   <a:srgbClr val="111111"/>
                 </a:solidFill>
+                <a:latin typeface="Pretendard"/>
+                <a:ea typeface="Pretendard"/>
+                <a:cs typeface="Pretendard"/>
               </a:rPr>
               <a:t>“한 문장 인용은</a:t>
             </a:r>
@@ -2326,6 +2446,9 @@
                 <a:solidFill>
                   <a:srgbClr val="111111"/>
                 </a:solidFill>
+                <a:latin typeface="Pretendard"/>
+                <a:ea typeface="Pretendard"/>
+                <a:cs typeface="Pretendard"/>
               </a:defRPr>
             </a:pPr>
             <a:r>
@@ -2333,6 +2456,9 @@
                 <a:solidFill>
                   <a:srgbClr val="111111"/>
                 </a:solidFill>
+                <a:latin typeface="Pretendard"/>
+                <a:ea typeface="Pretendard"/>
+                <a:cs typeface="Pretendard"/>
               </a:rPr>
               <a:t>문제를 선명하게 만듭니다.”</a:t>
             </a:r>
@@ -2344,7 +2470,7 @@
           <p:cNvPr id="2" name="image-placeholder-quote">
             <a:extLst xmlns:a="http://schemas.openxmlformats.org/drawingml/2006/main">
               <a:ext uri="{FF2B5EF4-FFF2-40B4-BE49-F238E27FC236}">
-                <a16:creationId xmlns:a16="http://schemas.microsoft.com/office/drawing/2014/main" id="{A31099DC-C13B-4F81-AB9D-B10E6DBC79CA}"/>
+                <a16:creationId xmlns:a16="http://schemas.microsoft.com/office/drawing/2014/main" id="{3CA9F3ED-AE17-4448-B4E8-C9776FF30798}"/>
               </a:ext>
             </a:extLst>
           </p:cNvPr>
@@ -2377,7 +2503,7 @@
           <p:cNvPr id="3" name="image-placeholder-quote-label">
             <a:extLst xmlns:a="http://schemas.openxmlformats.org/drawingml/2006/main">
               <a:ext uri="{FF2B5EF4-FFF2-40B4-BE49-F238E27FC236}">
-                <a16:creationId xmlns:a16="http://schemas.microsoft.com/office/drawing/2014/main" id="{09160B45-90D2-4A0C-B9D7-F550717D8E6B}"/>
+                <a16:creationId xmlns:a16="http://schemas.microsoft.com/office/drawing/2014/main" id="{245959F4-22DC-4BAF-B92D-122C607DAC0A}"/>
               </a:ext>
             </a:extLst>
           </p:cNvPr>
@@ -2409,6 +2535,9 @@
                 <a:solidFill>
                   <a:srgbClr val="555555"/>
                 </a:solidFill>
+                <a:latin typeface="Pretendard"/>
+                <a:ea typeface="Pretendard"/>
+                <a:cs typeface="Pretendard"/>
               </a:defRPr>
             </a:pPr>
             <a:r>
@@ -2416,6 +2545,9 @@
                 <a:solidFill>
                   <a:srgbClr val="555555"/>
                 </a:solidFill>
+                <a:latin typeface="Pretendard"/>
+                <a:ea typeface="Pretendard"/>
+                <a:cs typeface="Pretendard"/>
               </a:rPr>
               <a:t>사진: 발언 중인 인물 · 가로</a:t>
             </a:r>
@@ -2427,7 +2559,7 @@
           <p:cNvPr id="4" name="source-line">
             <a:extLst xmlns:a="http://schemas.openxmlformats.org/drawingml/2006/main">
               <a:ext uri="{FF2B5EF4-FFF2-40B4-BE49-F238E27FC236}">
-                <a16:creationId xmlns:a16="http://schemas.microsoft.com/office/drawing/2014/main" id="{66D583E5-7591-417B-AA77-C2EF5AF4E069}"/>
+                <a16:creationId xmlns:a16="http://schemas.microsoft.com/office/drawing/2014/main" id="{E9AEEC0F-D2E6-41D1-8DE5-3E9D6BD3E024}"/>
               </a:ext>
             </a:extLst>
           </p:cNvPr>
@@ -2459,6 +2591,9 @@
                 <a:solidFill>
                   <a:srgbClr val="666666"/>
                 </a:solidFill>
+                <a:latin typeface="Pretendard"/>
+                <a:ea typeface="Pretendard"/>
+                <a:cs typeface="Pretendard"/>
               </a:defRPr>
             </a:pPr>
             <a:r>
@@ -2466,6 +2601,9 @@
                 <a:solidFill>
                   <a:srgbClr val="666666"/>
                 </a:solidFill>
+                <a:latin typeface="Pretendard"/>
+                <a:ea typeface="Pretendard"/>
+                <a:cs typeface="Pretendard"/>
               </a:rPr>
               <a:t>인용 출처: 최종 자료에서 확인</a:t>
             </a:r>
@@ -2475,7 +2613,7 @@
     </p:spTree>
     <p:extLst>
       <p:ext uri="{BB962C8B-B14F-4D97-AF65-F5344CB8AC3E}">
-        <p14:creationId xmlns:p14="http://schemas.microsoft.com/office/powerpoint/2010/main" val="147211154"/>
+        <p14:creationId xmlns:p14="http://schemas.microsoft.com/office/powerpoint/2010/main" val="1344894422"/>
       </p:ext>
     </p:extLst>
   </p:cSld>
@@ -2506,7 +2644,7 @@
           <p:cNvPr id="3" name="close-title">
             <a:extLst xmlns:a="http://schemas.openxmlformats.org/drawingml/2006/main">
               <a:ext uri="{FF2B5EF4-FFF2-40B4-BE49-F238E27FC236}">
-                <a16:creationId xmlns:a16="http://schemas.microsoft.com/office/drawing/2014/main" id="{A65CEFBF-CF27-41D5-B8C0-C47468078D89}"/>
+                <a16:creationId xmlns:a16="http://schemas.microsoft.com/office/drawing/2014/main" id="{61D8D7C3-CF11-420E-8DD7-E08363296EDC}"/>
               </a:ext>
             </a:extLst>
           </p:cNvPr>
@@ -2538,6 +2676,9 @@
                 <a:solidFill>
                   <a:srgbClr val="111111"/>
                 </a:solidFill>
+                <a:latin typeface="Pretendard"/>
+                <a:ea typeface="Pretendard"/>
+                <a:cs typeface="Pretendard"/>
               </a:defRPr>
             </a:pPr>
             <a:r>
@@ -2545,6 +2686,9 @@
                 <a:solidFill>
                   <a:srgbClr val="111111"/>
                 </a:solidFill>
+                <a:latin typeface="Pretendard"/>
+                <a:ea typeface="Pretendard"/>
+                <a:cs typeface="Pretendard"/>
               </a:rPr>
               <a:t>좋은 마무리는</a:t>
             </a:r>
@@ -2555,6 +2699,9 @@
                 <a:solidFill>
                   <a:srgbClr val="111111"/>
                 </a:solidFill>
+                <a:latin typeface="Pretendard"/>
+                <a:ea typeface="Pretendard"/>
+                <a:cs typeface="Pretendard"/>
               </a:defRPr>
             </a:pPr>
             <a:r>
@@ -2562,6 +2709,9 @@
                 <a:solidFill>
                   <a:srgbClr val="111111"/>
                 </a:solidFill>
+                <a:latin typeface="Pretendard"/>
+                <a:ea typeface="Pretendard"/>
+                <a:cs typeface="Pretendard"/>
               </a:rPr>
               <a:t>다음 행동을 남깁니다</a:t>
             </a:r>
@@ -2573,7 +2723,7 @@
           <p:cNvPr id="2" name="close-body">
             <a:extLst xmlns:a="http://schemas.openxmlformats.org/drawingml/2006/main">
               <a:ext uri="{FF2B5EF4-FFF2-40B4-BE49-F238E27FC236}">
-                <a16:creationId xmlns:a16="http://schemas.microsoft.com/office/drawing/2014/main" id="{744BBBD8-FC78-4FAD-BD81-B01522577425}"/>
+                <a16:creationId xmlns:a16="http://schemas.microsoft.com/office/drawing/2014/main" id="{1E9C8728-AB34-4A32-8ABB-B8219547CAE2}"/>
               </a:ext>
             </a:extLst>
           </p:cNvPr>
@@ -2605,6 +2755,9 @@
                 <a:solidFill>
                   <a:srgbClr val="333333"/>
                 </a:solidFill>
+                <a:latin typeface="Pretendard"/>
+                <a:ea typeface="Pretendard"/>
+                <a:cs typeface="Pretendard"/>
               </a:defRPr>
             </a:pPr>
             <a:r>
@@ -2612,6 +2765,9 @@
                 <a:solidFill>
                   <a:srgbClr val="333333"/>
                 </a:solidFill>
+                <a:latin typeface="Pretendard"/>
+                <a:ea typeface="Pretendard"/>
+                <a:cs typeface="Pretendard"/>
               </a:rPr>
               <a:t>결론 한 문장과,</a:t>
             </a:r>
@@ -2622,6 +2778,9 @@
                 <a:solidFill>
                   <a:srgbClr val="333333"/>
                 </a:solidFill>
+                <a:latin typeface="Pretendard"/>
+                <a:ea typeface="Pretendard"/>
+                <a:cs typeface="Pretendard"/>
               </a:defRPr>
             </a:pPr>
             <a:r>
@@ -2629,6 +2788,9 @@
                 <a:solidFill>
                   <a:srgbClr val="333333"/>
                 </a:solidFill>
+                <a:latin typeface="Pretendard"/>
+                <a:ea typeface="Pretendard"/>
+                <a:cs typeface="Pretendard"/>
               </a:rPr>
               <a:t>청중이 기억하거나 결정할 한 가지를 적습니다.</a:t>
             </a:r>
@@ -2638,7 +2800,7 @@
     </p:spTree>
     <p:extLst>
       <p:ext uri="{BB962C8B-B14F-4D97-AF65-F5344CB8AC3E}">
-        <p14:creationId xmlns:p14="http://schemas.microsoft.com/office/powerpoint/2010/main" val="1894527331"/>
+        <p14:creationId xmlns:p14="http://schemas.microsoft.com/office/powerpoint/2010/main" val="1576972714"/>
       </p:ext>
     </p:extLst>
   </p:cSld>
@@ -2688,14 +2850,14 @@
     </a:clrScheme>
     <a:fontScheme name="Office">
       <a:majorFont>
-        <a:latin typeface="Calibri Light"/>
-        <a:ea typeface="Calibri Light"/>
-        <a:cs typeface="Calibri Light"/>
+        <a:latin typeface="Pretendard"/>
+        <a:ea typeface="Pretendard"/>
+        <a:cs typeface="Pretendard"/>
       </a:majorFont>
       <a:minorFont>
-        <a:latin typeface="Calibri"/>
-        <a:ea typeface="Calibri"/>
-        <a:cs typeface="Calibri"/>
+        <a:latin typeface="Pretendard"/>
+        <a:ea typeface="Pretendard"/>
+        <a:cs typeface="Pretendard"/>
       </a:minorFont>
     </a:fontScheme>
     <a:fmtScheme name="ChatGPT">

</xml_diff>